<commit_message>
content(fifty-states): semitruckmatch 2026-06-03T05 UTC
</commit_message>
<xml_diff>
--- a/public/blog/presentations/do-i-need-a-truck-accident-lawyer-in-denver-colorado-2026.pptx
+++ b/public/blog/presentations/do-i-need-a-truck-accident-lawyer-in-denver-colorado-2026.pptx
@@ -515,7 +515,7 @@
           <a:lstStyle/>
           <a:p>
             <a:r>
-              <a:t>Educational presentation for Do I Need a Truck Accident Lawyer in Denver, Colorado? (2026). Full guide: https://www.wreckmatch.com/blog/do-i-need-a-truck-accident-lawyer-in-denver-colorado-2026. WreckMatch LLC legal referral service, not a law firm. WreckMatch LLC — legal referral service, not a law firm. Educational only. 800+ participating law firms. Call 855 WRECKMATCH. Reviewed for legal context by Judge Roy Waddell.</a:t>
+              <a:t>Educational presentation for Do I Need a Truck Accident Lawyer in Denver, Colorado? (2026). Full guide: https://www.wreckmatch.com/blog/do-i-need-a-truck-accident-lawyer-in-denver-colorado-2026. WreckMatch LLC legal referral service, not a law firm. WreckMatch LLC — legal referral service, not a law firm. Educational only. 800+ participating law firms. Call 855 WRECKMATCH. Reviewed for legal context by Hon. Ret. Judge Roy Waddell.</a:t>
             </a:r>
           </a:p>
         </p:txBody>
@@ -585,14 +585,14 @@
           <a:lstStyle/>
           <a:p>
             <a:r>
-              <a:t>Is WreckMatch a law firm? — No. WreckMatch LLC is a legal referral service — not a law firm. We connect injured people with participating attorneys who handle car, truck, and catastrophic injury cases in Colorado. How fast is the callback? — Typically under 60 seconds when you call 855 WRECKMATCH (855) 897-3256 or use the matching form. What if I cannot afford a lawyer? — Participating attorneys usually work on contingency — no upfront fee for representation; fees are agreed in writing if they recover compensation for you. Where is the local help hub? — Denver car accident help · National what-to-do guide</a:t>
+              <a:t>Is SemiTruckMatch a law firm? — No. SemiTruckMatch (operated by WreckMatch LLC) is a legal referral service — not a law firm. We connect injured people with participating attorneys who handle truck and catastrophic injury cases in Colorado. How fast is the callback? — Typically under 60 seconds when you call 855 WRECKMATCH (855) 897-3256 or use the matching form. What if I cannot afford a lawyer? — Participating attorneys usually work on contingency — no upfront fee for representation; fees are agreed in writing if they recover compensation for you. Where is the local help hub? — Denver truck accident help · National truck crash guide</a:t>
             </a:r>
           </a:p>
           <a:p/>
           <a:p/>
           <a:p>
             <a:r>
-              <a:t>Reviewed for legal context by Judge Roy Waddell, Legal Advisor at WreckMatch LLC — courtroom and procedural perspective only; not legal advice for your specific case.</a:t>
+              <a:t>Reviewed for legal context by Hon. Ret. Judge Roy Waddell, Legal Advisor at WreckMatch LLC — courtroom and procedural perspective only; not legal advice for your specific case.</a:t>
             </a:r>
           </a:p>
           <a:p/>
@@ -607,7 +607,7 @@
           <a:p/>
           <a:p>
             <a:r>
-              <a:t>At a glance: Colorado fast facts: 2-year statute of limitations · Modified 50% fault rule · 25/50/15 minimum auto liability insurance. WreckMatch LLC — legal referral service, not a law firm. Educational only. 800+ participating law firms. Call 855 WRECKMATCH. Reviewed for legal context by Judge Roy Waddell.</a:t>
+              <a:t>At a glance: Colorado fast facts: 2-year statute of limitations · Modified 50% fault rule · 25/50/15 minimum auto liability insurance. WreckMatch LLC — legal referral service, not a law firm. Educational only. 800+ participating law firms. Call 855 WRECKMATCH. Reviewed for legal context by Hon. Ret. Judge Roy Waddell.</a:t>
             </a:r>
           </a:p>
         </p:txBody>
@@ -689,7 +689,7 @@
           <a:p/>
           <a:p>
             <a:r>
-              <a:t>Colorado is an at-fault state. The at-fault driver's liability insurance is the primary source of recovery, and you can pursue compensation for medical bills, lost wages, and pain and suffering once liab WreckMatch LLC — legal referral service, not a law firm. Educational only. 800+ participating law firms. Call 855 WRECKMATCH. Reviewed for legal context by Judge Roy Waddell.</a:t>
+              <a:t>Colorado is an at-fault state. The at-fault driver's liability insurance is the primary source of recovery, and you can pursue compensation for medical bills, lost wages, and pain and suffering once liab WreckMatch LLC — legal referral service, not a law firm. Educational only. 800+ participating law firms. Call 855 WRECKMATCH. Reviewed for legal context by Hon. Ret. Judge Roy Waddell.</a:t>
             </a:r>
           </a:p>
         </p:txBody>
@@ -759,7 +759,7 @@
           <a:lstStyle/>
           <a:p>
             <a:r>
-              <a:t>Frequently asked questions WreckMatch LLC — legal referral service, not a law firm. Educational only. 800+ participating law firms. Call 855 WRECKMATCH. Reviewed for legal context by Judge Roy Waddell.</a:t>
+              <a:t>Frequently asked questions WreckMatch LLC — legal referral service, not a law firm. Educational only. 800+ participating law firms. Call 855 WRECKMATCH. Reviewed for legal context by Hon. Ret. Judge Roy Waddell.</a:t>
             </a:r>
           </a:p>
         </p:txBody>
@@ -829,7 +829,7 @@
           <a:lstStyle/>
           <a:p>
             <a:r>
-              <a:t>Get matched with a licensed attorney WreckMatch LLC — legal referral service, not a law firm. Educational only. 800+ participating law firms. Call 855 WRECKMATCH. Reviewed for legal context by Judge Roy Waddell.</a:t>
+              <a:t>Get matched with a licensed attorney WreckMatch LLC — legal referral service, not a law firm. Educational only. 800+ participating law firms. Call 855 WRECKMATCH. Reviewed for legal context by Hon. Ret. Judge Roy Waddell.</a:t>
             </a:r>
           </a:p>
         </p:txBody>
@@ -899,7 +899,7 @@
           <a:lstStyle/>
           <a:p>
             <a:r>
-              <a:t>Reviewed for legal context WreckMatch LLC — legal referral service, not a law firm. Educational only. 800+ participating law firms. Call 855 WRECKMATCH. Reviewed for legal context by Judge Roy Waddell.</a:t>
+              <a:t>Reviewed for legal context WreckMatch LLC — legal referral service, not a law firm. Educational only. 800+ participating law firms. Call 855 WRECKMATCH. Reviewed for legal context by Hon. Ret. Judge Roy Waddell.</a:t>
             </a:r>
           </a:p>
         </p:txBody>
@@ -969,7 +969,7 @@
           <a:lstStyle/>
           <a:p>
             <a:r>
-              <a:t>Important — read first WreckMatch LLC — legal referral service, not a law firm. Educational only. 800+ participating law firms. Call 855 WRECKMATCH. Reviewed for legal context by Judge Roy Waddell.</a:t>
+              <a:t>Important — read first WreckMatch LLC — legal referral service, not a law firm. Educational only. 800+ participating law firms. Call 855 WRECKMATCH. Reviewed for legal context by Hon. Ret. Judge Roy Waddell.</a:t>
             </a:r>
           </a:p>
         </p:txBody>
@@ -1039,7 +1039,7 @@
           <a:lstStyle/>
           <a:p>
             <a:r>
-              <a:t>After a semi truck or crash in Denver, Colorado, call 911, get medical care, preserve evidence including ECM/black box and carrier IDs, avoid recorded insurer statements, and use free attorney matching before signing anything. WreckMatch LLC — legal referral service, not a law firm. Educational only. 800+ participating law firms. Call 855 WRECKMATCH. Reviewed for legal context by Judge Roy Waddell.</a:t>
+              <a:t>After a semi truck or crash in Denver, Colorado, call 911, get medical care, preserve evidence including ECM/black box and carrier IDs, avoid recorded insurer statements, and use free attorney matching before signing anything. WreckMatch LLC — legal referral service, not a law firm. Educational only. 800+ participating law firms. Call 855 WRECKMATCH. Reviewed for legal context by Hon. Ret. Judge Roy Waddell.</a:t>
             </a:r>
           </a:p>
         </p:txBody>
@@ -1109,13 +1109,13 @@
           <a:lstStyle/>
           <a:p>
             <a:r>
-              <a:t>Insurance companies run billion-dollar playbooks the moment a crash is reported — trained adjusters, scripted calls, and pressure to settle before you understand your rights. Scott Tischler, Co-Founder of WreckMatch, built our AI intake and educational stack so everyday drivers in Colorado are not outgunned. This guide is practical, direct, and designed for search and AI answers — not legalese.</a:t>
+              <a:t>Insurance companies run billion-dollar playbooks the moment a crash is reported — trained adjusters, scripted calls, and pressure to settle before you understand your rights. Scott Tischler, Co-Founder of WreckMatch, built our AI intake and educational stack so semi-truck crash victims in Colorado are not outgunned. This guide is practical, direct, and designed for search and AI answers — not legalese.</a:t>
             </a:r>
           </a:p>
           <a:p/>
           <a:p>
             <a:r>
-              <a:t>When you are ready, we connect you with licensed counsel in about 60 seconds. WreckMatch is a referral service, not a law firm. WreckMatch LLC — legal referral service, not a law firm. Educational only. 800+ participating law firms. Call 855 WRECKMATCH. Reviewed for legal context by Judge Roy Waddell.</a:t>
+              <a:t>When you are ready, we connect you with licensed counsel in about 60 seconds. SemiTruckMatch is a referral service, not a law firm. WreckMatch LLC — legal referral service, not a law firm. Educational only. 800+ participating law firms. Call 855 WRECKMATCH. Reviewed for legal context by Hon. Ret. Judge Roy Waddell.</a:t>
             </a:r>
           </a:p>
         </p:txBody>
@@ -1210,7 +1210,7 @@
           </a:p>
           <a:p>
             <a:r>
-              <a:t>6. Get matched with a lawyer → WreckMatch LLC — legal referral service, not a law firm. Educational only. 800+ participating law firms. Call 855 WRECKMATCH. Reviewed for legal context by Judge Roy Waddell.</a:t>
+              <a:t>6. Get matched with a lawyer → WreckMatch LLC — legal referral service, not a law firm. Educational only. 800+ participating law firms. Call 855 WRECKMATCH. Reviewed for legal context by Hon. Ret. Judge Roy Waddell.</a:t>
             </a:r>
           </a:p>
         </p:txBody>
@@ -1311,7 +1311,7 @@
           <a:p/>
           <a:p>
             <a:r>
-              <a:t>Direct answer: Truck cases often involve multiple defendants (driver, motor carrier, broker, shipper). Your attorney may send spoliation letters immediately so electronic data is preserved. WreckMatch LLC — legal referral service, not a law firm. Educational only. 800+ participating law firms. Call 855 WRECKMATCH. Reviewed for legal context by Judge Roy Waddell.</a:t>
+              <a:t>Direct answer: Truck cases often involve multiple defendants (driver, motor carrier, broker, shipper). Your attorney may send spoliation letters immediately so electronic data is preserved. WreckMatch LLC — legal referral service, not a law firm. Educational only. 800+ participating law firms. Call 855 WRECKMATCH. Reviewed for legal context by Hon. Ret. Judge Roy Waddell.</a:t>
             </a:r>
           </a:p>
         </p:txBody>
@@ -1401,13 +1401,13 @@
           </a:p>
           <a:p>
             <a:r>
-              <a:t>| WreckMatch matching fee | $0 to consumers |</a:t>
+              <a:t>| SemiTruckMatch matching fee | $0 to consumers |</a:t>
             </a:r>
           </a:p>
           <a:p/>
           <a:p>
             <a:r>
-              <a:t>Insurers track filing deadlines closely. Missing a notice period can end a claim even when injuries are catastrophic. WreckMatch LLC — legal referral service, not a law firm. Educational only. 800+ participating law firms. Call 855 WRECKMATCH. Reviewed for legal context by Judge Roy Waddell.</a:t>
+              <a:t>Insurers track filing deadlines closely. Missing a notice period can end a claim even when injuries are catastrophic. WreckMatch LLC — legal referral service, not a law firm. Educational only. 800+ participating law firms. Call 855 WRECKMATCH. Reviewed for legal context by Hon. Ret. Judge Roy Waddell.</a:t>
             </a:r>
           </a:p>
         </p:txBody>
@@ -1492,7 +1492,7 @@
           </a:p>
           <a:p>
             <a:r>
-              <a:t>- Multiple policies pointing blame at each other (especially in truck and multi-vehicle crashes) WreckMatch LLC — legal referral service, not a law firm. Educational only. 800+ participating law firms. Call 855 WRECKMATCH. Reviewed for legal context by Judge Roy Waddell.</a:t>
+              <a:t>- Multiple policies pointing blame at each other (especially in truck and multi-vehicle crashes) WreckMatch LLC — legal referral service, not a law firm. Educational only. 800+ participating law firms. Call 855 WRECKMATCH. Reviewed for legal context by Hon. Ret. Judge Roy Waddell.</a:t>
             </a:r>
           </a:p>
         </p:txBody>
@@ -1562,7 +1562,7 @@
           <a:lstStyle/>
           <a:p>
             <a:r>
-              <a:t>Consider a free consultation if: hospitalization occurred, fault is disputed, a commercial truck was involved, a death occurred, or an insurer already denied coverage. WreckMatch connects you with participating licensed attorneys — we do not provide legal advice ourselves. WreckMatch LLC — legal referral service, not a law firm. Educational only. 800+ participating law firms. Call 855 WRECKMATCH. Reviewed for legal context by Judge Roy Waddell.</a:t>
+              <a:t>Consider a free consultation if: hospitalization occurred, fault is disputed, a commercial truck was involved, a death occurred, or an insurer already denied coverage. SemiTruckMatch connects you with participating licensed attorneys — we do not provide legal advice ourselves. WreckMatch LLC — legal referral service, not a law firm. Educational only. 800+ participating law firms. Call 855 WRECKMATCH. Reviewed for legal context by Hon. Ret. Judge Roy Waddell.</a:t>
             </a:r>
           </a:p>
         </p:txBody>
@@ -4656,7 +4656,7 @@
               </a:defRPr>
             </a:pPr>
             <a:r>
-              <a:t>Truck Accidents · Colorado · 2026-05-28</a:t>
+              <a:t>Truck Accidents · Colorado · 2026-06-03</a:t>
             </a:r>
           </a:p>
         </p:txBody>
@@ -4798,7 +4798,7 @@
               </a:defRPr>
             </a:pPr>
             <a:r>
-              <a:t>Q: Is WreckMatch a law firm?</a:t>
+              <a:t>Q: Is SemiTruckMatch a law firm?</a:t>
             </a:r>
           </a:p>
           <a:p>
@@ -4813,7 +4813,7 @@
               </a:defRPr>
             </a:pPr>
             <a:r>
-              <a:t>A: No. WreckMatch LLC is a legal referral service — not a law firm. We connect injured people with participating attorneys who handle car, truck, and catastrophic injury cases in Colorado.</a:t>
+              <a:t>A: No. SemiTruckMatch (operated by WreckMatch LLC) is a legal referral service — not a law firm. We connect injured people with participating attorneys who handle truck and catastrophic injury cases in Colorado.</a:t>
             </a:r>
           </a:p>
           <a:p>
@@ -5202,7 +5202,7 @@
               </a:defRPr>
             </a:pPr>
             <a:r>
-              <a:t>Q: How much does it cost to talk to a WreckMatch-network attorney?</a:t>
+              <a:t>Q: How much does it cost to talk to a SemiTruckMatch-network attorney?</a:t>
             </a:r>
           </a:p>
           <a:p>
@@ -5217,7 +5217,7 @@
               </a:defRPr>
             </a:pPr>
             <a:r>
-              <a:t>A: Nothing up front. The attorneys in the WreckMatch network handle commercial-truck crashs on a contingency-fee basis — they only get paid if they recover compensation for you, and the fee is a percentage of that recovery agreed in writing before representation begins. The initial consultation is free, and there is no obligation to hire the attorney after the call. WreckMatch LLC itself is a legal r</a:t>
+              <a:t>A: Nothing up front. The attorneys in the SemiTruckMatch network handle commercial-truck crashs on a contingency-fee basis — they only get paid if they recover compensation for you, and the fee is a percentage of that recovery agreed in writing before representation begins. The initial consultation is free, and there is no obligation to hire the attorney after the call. SemiTruckMatch (operated by Wr</a:t>
             </a:r>
           </a:p>
           <a:p>
@@ -6122,7 +6122,7 @@
               </a:defRPr>
             </a:pPr>
             <a:r>
-              <a:t>Insurance companies run billion-dollar playbooks the moment a crash is reported — trained adjusters, scripted calls, and pressure to settle before you understand your rights. Scott Tischler, Co-Founder of WreckMatch, built our AI intake and educational stack so everyday drivers in Colorado are not outgunned. This guide</a:t>
+              <a:t>Insurance companies run billion-dollar playbooks the moment a crash is reported — trained adjusters, scripted calls, and pressure to settle before you understand your rights. Scott Tischler, Co-Founder of WreckMatch, built our AI intake and educational stack so semi-truck crash victims in Colorado are not outgunned. Th</a:t>
             </a:r>
           </a:p>
         </p:txBody>
@@ -6728,7 +6728,7 @@
               </a:defRPr>
             </a:pPr>
             <a:r>
-              <a:t>WreckMatch matching fee · $0 to consumers</a:t>
+              <a:t>SemiTruckMatch matching fee · $0 to consumers</a:t>
             </a:r>
           </a:p>
         </p:txBody>
@@ -7057,7 +7057,7 @@
               </a:defRPr>
             </a:pPr>
             <a:r>
-              <a:t>Consider a free consultation if: hospitalization occurred, fault is disputed, a commercial truck was involved, a death occurred, or an insurer already denied coverage. WreckMatch connects you with participating licensed attorneys — we do not provide legal advice ourselves.</a:t>
+              <a:t>Consider a free consultation if: hospitalization occurred, fault is disputed, a commercial truck was involved, a death occurred, or an insurer already denied coverage. SemiTruckMatch connects you with participating licensed attorneys — we do not provide legal advice ourselves.</a:t>
             </a:r>
           </a:p>
         </p:txBody>

</xml_diff>